<commit_message>
Update PostOp Pal FINAL presentation.pptx
Updated link to visual studio code python file embedded in PPT
</commit_message>
<xml_diff>
--- a/PostOp Pal FINAL presentation.pptx
+++ b/PostOp Pal FINAL presentation.pptx
@@ -5,15 +5,14 @@
     <p:sldMasterId id="2147483648" r:id="rId4"/>
   </p:sldMasterIdLst>
   <p:notesMasterIdLst>
-    <p:notesMasterId r:id="rId11"/>
+    <p:notesMasterId r:id="rId10"/>
   </p:notesMasterIdLst>
   <p:sldIdLst>
     <p:sldId id="334" r:id="rId5"/>
     <p:sldId id="319" r:id="rId6"/>
     <p:sldId id="320" r:id="rId7"/>
-    <p:sldId id="323" r:id="rId8"/>
-    <p:sldId id="336" r:id="rId9"/>
-    <p:sldId id="335" r:id="rId10"/>
+    <p:sldId id="336" r:id="rId8"/>
+    <p:sldId id="335" r:id="rId9"/>
   </p:sldIdLst>
   <p:sldSz cx="12192000" cy="6858000"/>
   <p:notesSz cx="6858000" cy="9144000"/>
@@ -214,7 +213,7 @@
           <a:p>
             <a:fld id="{AF8710A2-1535-B147-B3BB-C1589046255C}" type="datetimeFigureOut">
               <a:rPr lang="en-US" smtClean="0"/>
-              <a:t>5/2/2026</a:t>
+              <a:t>5/4/2026</a:t>
             </a:fld>
             <a:endParaRPr lang="en-US" dirty="0"/>
           </a:p>
@@ -818,129 +817,6 @@
   <p:cSld>
     <p:spTree>
       <p:nvGrpSpPr>
-        <p:cNvPr id="1" name=""/>
-        <p:cNvGrpSpPr/>
-        <p:nvPr/>
-      </p:nvGrpSpPr>
-      <p:grpSpPr>
-        <a:xfrm>
-          <a:off x="0" y="0"/>
-          <a:ext cx="0" cy="0"/>
-          <a:chOff x="0" y="0"/>
-          <a:chExt cx="0" cy="0"/>
-        </a:xfrm>
-      </p:grpSpPr>
-      <p:sp>
-        <p:nvSpPr>
-          <p:cNvPr id="2" name="Slide Image Placeholder 1"/>
-          <p:cNvSpPr>
-            <a:spLocks noGrp="1" noRot="1" noChangeAspect="1"/>
-          </p:cNvSpPr>
-          <p:nvPr>
-            <p:ph type="sldImg"/>
-          </p:nvPr>
-        </p:nvSpPr>
-        <p:spPr/>
-      </p:sp>
-      <p:sp>
-        <p:nvSpPr>
-          <p:cNvPr id="3" name="Notes Placeholder 2"/>
-          <p:cNvSpPr>
-            <a:spLocks noGrp="1"/>
-          </p:cNvSpPr>
-          <p:nvPr>
-            <p:ph type="body" idx="1"/>
-          </p:nvPr>
-        </p:nvSpPr>
-        <p:spPr/>
-        <p:txBody>
-          <a:bodyPr/>
-          <a:lstStyle/>
-          <a:p>
-            <a:r>
-              <a:rPr lang="en-US" dirty="0"/>
-              <a:t>The patient starts with selected the date of surgery and type of surgery. </a:t>
-            </a:r>
-          </a:p>
-          <a:p>
-            <a:endParaRPr lang="en-US" dirty="0"/>
-          </a:p>
-          <a:p>
-            <a:r>
-              <a:rPr lang="en-US" dirty="0"/>
-              <a:t>This will determine the phase you enter.  There is a screening question and as along as you meet criteria, you can proceed with the exercises.  </a:t>
-            </a:r>
-          </a:p>
-          <a:p>
-            <a:endParaRPr lang="en-US" dirty="0"/>
-          </a:p>
-          <a:p>
-            <a:r>
-              <a:rPr lang="en-US" dirty="0"/>
-              <a:t>If you do not meet criteria, for example if pain levels are too high, the program will request for you to complete another action before you try again.  </a:t>
-            </a:r>
-          </a:p>
-          <a:p>
-            <a:endParaRPr lang="en-US" dirty="0"/>
-          </a:p>
-          <a:p>
-            <a:r>
-              <a:rPr lang="en-US" dirty="0"/>
-              <a:t>After 12 weeks, your precautions for total hip will be lifted. </a:t>
-            </a:r>
-          </a:p>
-          <a:p>
-            <a:endParaRPr lang="en-US" dirty="0"/>
-          </a:p>
-          <a:p>
-            <a:r>
-              <a:rPr lang="en-US" dirty="0"/>
-              <a:t>If you have returned to normal function, the program will end.  </a:t>
-            </a:r>
-          </a:p>
-        </p:txBody>
-      </p:sp>
-      <p:sp>
-        <p:nvSpPr>
-          <p:cNvPr id="4" name="Slide Number Placeholder 3"/>
-          <p:cNvSpPr>
-            <a:spLocks noGrp="1"/>
-          </p:cNvSpPr>
-          <p:nvPr>
-            <p:ph type="sldNum" sz="quarter" idx="5"/>
-          </p:nvPr>
-        </p:nvSpPr>
-        <p:spPr/>
-        <p:txBody>
-          <a:bodyPr/>
-          <a:lstStyle/>
-          <a:p>
-            <a:fld id="{6BD99F43-FFA2-D94E-9493-556FC2A4F32F}" type="slidenum">
-              <a:rPr lang="en-US" smtClean="0"/>
-              <a:t>4</a:t>
-            </a:fld>
-            <a:endParaRPr lang="en-US" dirty="0"/>
-          </a:p>
-        </p:txBody>
-      </p:sp>
-    </p:spTree>
-    <p:extLst>
-      <p:ext uri="{BB962C8B-B14F-4D97-AF65-F5344CB8AC3E}">
-        <p14:creationId xmlns:p14="http://schemas.microsoft.com/office/powerpoint/2010/main" val="146796380"/>
-      </p:ext>
-    </p:extLst>
-  </p:cSld>
-  <p:clrMapOvr>
-    <a:masterClrMapping/>
-  </p:clrMapOvr>
-</p:notes>
-</file>
-
-<file path=ppt/notesSlides/notesSlide5.xml><?xml version="1.0" encoding="utf-8"?>
-<p:notes xmlns:a="http://schemas.openxmlformats.org/drawingml/2006/main" xmlns:r="http://schemas.openxmlformats.org/officeDocument/2006/relationships" xmlns:p="http://schemas.openxmlformats.org/presentationml/2006/main">
-  <p:cSld>
-    <p:spTree>
-      <p:nvGrpSpPr>
         <p:cNvPr id="1" name="">
           <a:extLst>
             <a:ext uri="{FF2B5EF4-FFF2-40B4-BE49-F238E27FC236}">
@@ -1087,7 +963,7 @@
           <a:p>
             <a:fld id="{6BD99F43-FFA2-D94E-9493-556FC2A4F32F}" type="slidenum">
               <a:rPr lang="en-US" smtClean="0"/>
-              <a:t>5</a:t>
+              <a:t>4</a:t>
             </a:fld>
             <a:endParaRPr lang="en-US" dirty="0"/>
           </a:p>
@@ -1106,7 +982,7 @@
 </p:notes>
 </file>
 
-<file path=ppt/notesSlides/notesSlide6.xml><?xml version="1.0" encoding="utf-8"?>
+<file path=ppt/notesSlides/notesSlide5.xml><?xml version="1.0" encoding="utf-8"?>
 <p:notes xmlns:a="http://schemas.openxmlformats.org/drawingml/2006/main" xmlns:r="http://schemas.openxmlformats.org/officeDocument/2006/relationships" xmlns:p="http://schemas.openxmlformats.org/presentationml/2006/main">
   <p:cSld>
     <p:spTree>
@@ -1252,7 +1128,7 @@
           <a:p>
             <a:fld id="{6BD99F43-FFA2-D94E-9493-556FC2A4F32F}" type="slidenum">
               <a:rPr lang="en-US" smtClean="0"/>
-              <a:t>6</a:t>
+              <a:t>5</a:t>
             </a:fld>
             <a:endParaRPr lang="en-US" dirty="0"/>
           </a:p>
@@ -15717,258 +15593,6 @@
   <p:cSld>
     <p:spTree>
       <p:nvGrpSpPr>
-        <p:cNvPr id="1" name=""/>
-        <p:cNvGrpSpPr/>
-        <p:nvPr/>
-      </p:nvGrpSpPr>
-      <p:grpSpPr>
-        <a:xfrm>
-          <a:off x="0" y="0"/>
-          <a:ext cx="0" cy="0"/>
-          <a:chOff x="0" y="0"/>
-          <a:chExt cx="0" cy="0"/>
-        </a:xfrm>
-      </p:grpSpPr>
-      <p:sp>
-        <p:nvSpPr>
-          <p:cNvPr id="3" name="Footer Placeholder 2">
-            <a:extLst>
-              <a:ext uri="{FF2B5EF4-FFF2-40B4-BE49-F238E27FC236}">
-                <a16:creationId xmlns:a16="http://schemas.microsoft.com/office/drawing/2014/main" id="{09672F13-D5A1-99D6-6699-F78CB161045F}"/>
-              </a:ext>
-            </a:extLst>
-          </p:cNvPr>
-          <p:cNvSpPr>
-            <a:spLocks noGrp="1"/>
-          </p:cNvSpPr>
-          <p:nvPr>
-            <p:ph type="ftr" sz="quarter" idx="10"/>
-          </p:nvPr>
-        </p:nvSpPr>
-        <p:spPr/>
-        <p:txBody>
-          <a:bodyPr/>
-          <a:lstStyle/>
-          <a:p>
-            <a:r>
-              <a:rPr lang="en-US" dirty="0"/>
-              <a:t>Fitness Presentation</a:t>
-            </a:r>
-          </a:p>
-        </p:txBody>
-      </p:sp>
-      <p:sp>
-        <p:nvSpPr>
-          <p:cNvPr id="4" name="Slide Number Placeholder 3">
-            <a:extLst>
-              <a:ext uri="{FF2B5EF4-FFF2-40B4-BE49-F238E27FC236}">
-                <a16:creationId xmlns:a16="http://schemas.microsoft.com/office/drawing/2014/main" id="{A9C5863A-2239-B76D-E785-5A656F160FE0}"/>
-              </a:ext>
-            </a:extLst>
-          </p:cNvPr>
-          <p:cNvSpPr>
-            <a:spLocks noGrp="1"/>
-          </p:cNvSpPr>
-          <p:nvPr>
-            <p:ph type="sldNum" sz="quarter" idx="11"/>
-          </p:nvPr>
-        </p:nvSpPr>
-        <p:spPr/>
-        <p:txBody>
-          <a:bodyPr/>
-          <a:lstStyle/>
-          <a:p>
-            <a:fld id="{294A09A9-5501-47C1-A89A-A340965A2BE2}" type="slidenum">
-              <a:rPr lang="en-US" smtClean="0"/>
-              <a:pPr/>
-              <a:t>4</a:t>
-            </a:fld>
-            <a:endParaRPr lang="en-US" dirty="0"/>
-          </a:p>
-        </p:txBody>
-      </p:sp>
-      <p:sp>
-        <p:nvSpPr>
-          <p:cNvPr id="16" name="Rectangle 15">
-            <a:extLst>
-              <a:ext uri="{FF2B5EF4-FFF2-40B4-BE49-F238E27FC236}">
-                <a16:creationId xmlns:a16="http://schemas.microsoft.com/office/drawing/2014/main" id="{189E1E3B-D35C-1288-B970-A29047BF26D5}"/>
-              </a:ext>
-            </a:extLst>
-          </p:cNvPr>
-          <p:cNvSpPr/>
-          <p:nvPr/>
-        </p:nvSpPr>
-        <p:spPr>
-          <a:xfrm>
-            <a:off x="648536" y="2118392"/>
-            <a:ext cx="2569934" cy="1754326"/>
-          </a:xfrm>
-          <a:prstGeom prst="rect">
-            <a:avLst/>
-          </a:prstGeom>
-          <a:noFill/>
-        </p:spPr>
-        <p:txBody>
-          <a:bodyPr wrap="none" lIns="91440" tIns="45720" rIns="91440" bIns="45720">
-            <a:spAutoFit/>
-          </a:bodyPr>
-          <a:lstStyle/>
-          <a:p>
-            <a:pPr algn="ctr"/>
-            <a:r>
-              <a:rPr lang="en-US" sz="5400" b="1" cap="none" spc="0" dirty="0">
-                <a:ln w="0"/>
-                <a:solidFill>
-                  <a:schemeClr val="accent1"/>
-                </a:solidFill>
-                <a:effectLst>
-                  <a:outerShdw blurRad="38100" dist="25400" dir="5400000" algn="ctr" rotWithShape="0">
-                    <a:srgbClr val="6E747A">
-                      <a:alpha val="43000"/>
-                    </a:srgbClr>
-                  </a:outerShdw>
-                </a:effectLst>
-              </a:rPr>
-              <a:t>Flow</a:t>
-            </a:r>
-          </a:p>
-          <a:p>
-            <a:pPr algn="ctr"/>
-            <a:r>
-              <a:rPr lang="en-US" sz="5400" b="1" dirty="0">
-                <a:ln w="0"/>
-                <a:solidFill>
-                  <a:schemeClr val="accent1"/>
-                </a:solidFill>
-                <a:effectLst>
-                  <a:outerShdw blurRad="38100" dist="25400" dir="5400000" algn="ctr" rotWithShape="0">
-                    <a:srgbClr val="6E747A">
-                      <a:alpha val="43000"/>
-                    </a:srgbClr>
-                  </a:outerShdw>
-                </a:effectLst>
-              </a:rPr>
-              <a:t>Diagram</a:t>
-            </a:r>
-            <a:endParaRPr lang="en-US" sz="5400" b="1" cap="none" spc="0" dirty="0">
-              <a:ln w="0"/>
-              <a:solidFill>
-                <a:schemeClr val="accent1"/>
-              </a:solidFill>
-              <a:effectLst>
-                <a:outerShdw blurRad="38100" dist="25400" dir="5400000" algn="ctr" rotWithShape="0">
-                  <a:srgbClr val="6E747A">
-                    <a:alpha val="43000"/>
-                  </a:srgbClr>
-                </a:outerShdw>
-              </a:effectLst>
-            </a:endParaRPr>
-          </a:p>
-        </p:txBody>
-      </p:sp>
-      <p:sp>
-        <p:nvSpPr>
-          <p:cNvPr id="18" name="Content Placeholder 17">
-            <a:extLst>
-              <a:ext uri="{FF2B5EF4-FFF2-40B4-BE49-F238E27FC236}">
-                <a16:creationId xmlns:a16="http://schemas.microsoft.com/office/drawing/2014/main" id="{B1818E3E-B394-EF81-CD0A-AE5DF3DD3827}"/>
-              </a:ext>
-            </a:extLst>
-          </p:cNvPr>
-          <p:cNvSpPr>
-            <a:spLocks noGrp="1"/>
-          </p:cNvSpPr>
-          <p:nvPr>
-            <p:ph sz="quarter" idx="12"/>
-          </p:nvPr>
-        </p:nvSpPr>
-        <p:spPr/>
-        <p:txBody>
-          <a:bodyPr/>
-          <a:lstStyle/>
-          <a:p>
-            <a:endParaRPr lang="en-US"/>
-          </a:p>
-        </p:txBody>
-      </p:sp>
-      <p:pic>
-        <p:nvPicPr>
-          <p:cNvPr id="1032" name="Picture 8">
-            <a:extLst>
-              <a:ext uri="{FF2B5EF4-FFF2-40B4-BE49-F238E27FC236}">
-                <a16:creationId xmlns:a16="http://schemas.microsoft.com/office/drawing/2014/main" id="{2296E1E8-0AA9-5909-250B-197ABAD350A0}"/>
-              </a:ext>
-            </a:extLst>
-          </p:cNvPr>
-          <p:cNvPicPr>
-            <a:picLocks noChangeAspect="1" noChangeArrowheads="1"/>
-          </p:cNvPicPr>
-          <p:nvPr/>
-        </p:nvPicPr>
-        <p:blipFill>
-          <a:blip r:embed="rId3">
-            <a:extLst>
-              <a:ext uri="{28A0092B-C50C-407E-A947-70E740481C1C}">
-                <a14:useLocalDpi xmlns:a14="http://schemas.microsoft.com/office/drawing/2010/main" val="0"/>
-              </a:ext>
-            </a:extLst>
-          </a:blip>
-          <a:srcRect/>
-          <a:stretch>
-            <a:fillRect/>
-          </a:stretch>
-        </p:blipFill>
-        <p:spPr bwMode="auto">
-          <a:xfrm>
-            <a:off x="3688099" y="-253951"/>
-            <a:ext cx="8776665" cy="7312477"/>
-          </a:xfrm>
-          <a:prstGeom prst="rect">
-            <a:avLst/>
-          </a:prstGeom>
-          <a:noFill/>
-          <a:extLst>
-            <a:ext uri="{909E8E84-426E-40DD-AFC4-6F175D3DCCD1}">
-              <a14:hiddenFill xmlns:a14="http://schemas.microsoft.com/office/drawing/2010/main">
-                <a:solidFill>
-                  <a:srgbClr val="FFFFFF"/>
-                </a:solidFill>
-              </a14:hiddenFill>
-            </a:ext>
-          </a:extLst>
-        </p:spPr>
-      </p:pic>
-    </p:spTree>
-    <p:extLst>
-      <p:ext uri="{BB962C8B-B14F-4D97-AF65-F5344CB8AC3E}">
-        <p14:creationId xmlns:p14="http://schemas.microsoft.com/office/powerpoint/2010/main" val="1789441374"/>
-      </p:ext>
-    </p:extLst>
-  </p:cSld>
-  <p:clrMapOvr>
-    <a:masterClrMapping/>
-  </p:clrMapOvr>
-  <mc:AlternateContent xmlns:mc="http://schemas.openxmlformats.org/markup-compatibility/2006" xmlns:p159="http://schemas.microsoft.com/office/powerpoint/2015/09/main">
-    <mc:Choice Requires="p159">
-      <p:transition xmlns:p14="http://schemas.microsoft.com/office/powerpoint/2010/main" spd="slow" p14:dur="2000">
-        <p159:morph option="byObject"/>
-      </p:transition>
-    </mc:Choice>
-    <mc:Fallback xmlns="">
-      <p:transition spd="slow">
-        <p:fade/>
-      </p:transition>
-    </mc:Fallback>
-  </mc:AlternateContent>
-</p:sld>
-</file>
-
-<file path=ppt/slides/slide5.xml><?xml version="1.0" encoding="utf-8"?>
-<p:sld xmlns:a="http://schemas.openxmlformats.org/drawingml/2006/main" xmlns:r="http://schemas.openxmlformats.org/officeDocument/2006/relationships" xmlns:p="http://schemas.openxmlformats.org/presentationml/2006/main">
-  <p:cSld>
-    <p:spTree>
-      <p:nvGrpSpPr>
         <p:cNvPr id="1" name="">
           <a:extLst>
             <a:ext uri="{FF2B5EF4-FFF2-40B4-BE49-F238E27FC236}">
@@ -16417,7 +16041,7 @@
       <p:sp>
         <p:nvSpPr>
           <p:cNvPr id="2" name="Action Button: Go Forward or Next 1">
-            <a:hlinkClick r:id="rId4" action="ppaction://hlinkfile" highlightClick="1"/>
+            <a:hlinkClick r:id="rId4" action="ppaction://hlinkfile"/>
             <a:extLst>
               <a:ext uri="{FF2B5EF4-FFF2-40B4-BE49-F238E27FC236}">
                 <a16:creationId xmlns:a16="http://schemas.microsoft.com/office/drawing/2014/main" id="{89AEE8D4-B87E-AFD3-D94F-D1E946903B63}"/>
@@ -16719,6 +16343,44 @@
           </a:p>
         </p:txBody>
       </p:sp>
+      <p:sp>
+        <p:nvSpPr>
+          <p:cNvPr id="3" name="TextBox 2">
+            <a:extLst>
+              <a:ext uri="{FF2B5EF4-FFF2-40B4-BE49-F238E27FC236}">
+                <a16:creationId xmlns:a16="http://schemas.microsoft.com/office/drawing/2014/main" id="{17353102-8F60-9BE6-DD47-F43DF765DD3E}"/>
+              </a:ext>
+            </a:extLst>
+          </p:cNvPr>
+          <p:cNvSpPr txBox="1"/>
+          <p:nvPr/>
+        </p:nvSpPr>
+        <p:spPr>
+          <a:xfrm>
+            <a:off x="10841" y="5364515"/>
+            <a:ext cx="5735866" cy="307777"/>
+          </a:xfrm>
+          <a:prstGeom prst="rect">
+            <a:avLst/>
+          </a:prstGeom>
+          <a:noFill/>
+        </p:spPr>
+        <p:txBody>
+          <a:bodyPr wrap="none" rtlCol="0">
+            <a:spAutoFit/>
+          </a:bodyPr>
+          <a:lstStyle/>
+          <a:p>
+            <a:r>
+              <a:rPr lang="en-US" sz="1400" dirty="0">
+                <a:hlinkClick r:id="rId5"/>
+              </a:rPr>
+              <a:t>GitHub - jsouth32/Judith-Southard-2026-HMI: Repository for HMI7540 · GitHub</a:t>
+            </a:r>
+            <a:endParaRPr lang="en-US" sz="1400" dirty="0"/>
+          </a:p>
+        </p:txBody>
+      </p:sp>
     </p:spTree>
     <p:extLst>
       <p:ext uri="{BB962C8B-B14F-4D97-AF65-F5344CB8AC3E}">
@@ -16744,7 +16406,7 @@
 </p:sld>
 </file>
 
-<file path=ppt/slides/slide6.xml><?xml version="1.0" encoding="utf-8"?>
+<file path=ppt/slides/slide5.xml><?xml version="1.0" encoding="utf-8"?>
 <p:sld xmlns:a="http://schemas.openxmlformats.org/drawingml/2006/main" xmlns:r="http://schemas.openxmlformats.org/officeDocument/2006/relationships" xmlns:p="http://schemas.openxmlformats.org/presentationml/2006/main">
   <p:cSld>
     <p:spTree>
@@ -17479,6 +17141,15 @@
 </file>
 
 <file path=customXml/item1.xml><?xml version="1.0" encoding="utf-8"?>
+<?mso-contentType ?>
+<FormTemplates xmlns="http://schemas.microsoft.com/sharepoint/v3/contenttype/forms">
+  <Display>DocumentLibraryForm</Display>
+  <Edit>DocumentLibraryForm</Edit>
+  <New>DocumentLibraryForm</New>
+</FormTemplates>
+</file>
+
+<file path=customXml/item2.xml><?xml version="1.0" encoding="utf-8"?>
 <p:properties xmlns:p="http://schemas.microsoft.com/office/2006/metadata/properties" xmlns:xsi="http://www.w3.org/2001/XMLSchema-instance" xmlns:pc="http://schemas.microsoft.com/office/infopath/2007/PartnerControls">
   <documentManagement>
     <_ip_UnifiedCompliancePolicyUIAction xmlns="http://schemas.microsoft.com/sharepoint/v3" xsi:nil="true"/>
@@ -17496,15 +17167,6 @@
     <MediaServiceKeyPoints xmlns="71af3243-3dd4-4a8d-8c0d-dd76da1f02a5" xsi:nil="true"/>
   </documentManagement>
 </p:properties>
-</file>
-
-<file path=customXml/item2.xml><?xml version="1.0" encoding="utf-8"?>
-<?mso-contentType ?>
-<FormTemplates xmlns="http://schemas.microsoft.com/sharepoint/v3/contenttype/forms">
-  <Display>DocumentLibraryForm</Display>
-  <Edit>DocumentLibraryForm</Edit>
-  <New>DocumentLibraryForm</New>
-</FormTemplates>
 </file>
 
 <file path=customXml/item3.xml><?xml version="1.0" encoding="utf-8"?>
@@ -17802,6 +17464,14 @@
 </file>
 
 <file path=customXml/itemProps1.xml><?xml version="1.0" encoding="utf-8"?>
+<ds:datastoreItem xmlns:ds="http://schemas.openxmlformats.org/officeDocument/2006/customXml" ds:itemID="{A04CDE3F-B8C2-4BD4-A62C-403E2F61E64B}">
+  <ds:schemaRefs>
+    <ds:schemaRef ds:uri="http://schemas.microsoft.com/sharepoint/v3/contenttype/forms"/>
+  </ds:schemaRefs>
+</ds:datastoreItem>
+</file>
+
+<file path=customXml/itemProps2.xml><?xml version="1.0" encoding="utf-8"?>
 <ds:datastoreItem xmlns:ds="http://schemas.openxmlformats.org/officeDocument/2006/customXml" ds:itemID="{F9075954-2B3E-4F12-B048-376C0BA053E0}">
   <ds:schemaRefs>
     <ds:schemaRef ds:uri="http://schemas.microsoft.com/office/2006/metadata/properties"/>
@@ -17809,14 +17479,6 @@
     <ds:schemaRef ds:uri="http://schemas.microsoft.com/sharepoint/v3"/>
     <ds:schemaRef ds:uri="71af3243-3dd4-4a8d-8c0d-dd76da1f02a5"/>
     <ds:schemaRef ds:uri="230e9df3-be65-4c73-a93b-d1236ebd677e"/>
-  </ds:schemaRefs>
-</ds:datastoreItem>
-</file>
-
-<file path=customXml/itemProps2.xml><?xml version="1.0" encoding="utf-8"?>
-<ds:datastoreItem xmlns:ds="http://schemas.openxmlformats.org/officeDocument/2006/customXml" ds:itemID="{A04CDE3F-B8C2-4BD4-A62C-403E2F61E64B}">
-  <ds:schemaRefs>
-    <ds:schemaRef ds:uri="http://schemas.microsoft.com/sharepoint/v3/contenttype/forms"/>
   </ds:schemaRefs>
 </ds:datastoreItem>
 </file>

</xml_diff>